<commit_message>
added and compared best results and updated notebook
</commit_message>
<xml_diff>
--- a/artifacts/full_curr_nonword_vs_preserve_summary.pptx
+++ b/artifacts/full_curr_nonword_vs_preserve_summary.pptx
@@ -15,6 +15,10 @@
     <p:sldId id="260" r:id="rId11"/>
     <p:sldId id="261" r:id="rId12"/>
     <p:sldId id="262" r:id="rId14"/>
+    <p:sldId id="263" r:id="rId15"/>
+    <p:sldId id="264" r:id="rId16"/>
+    <p:sldId id="265" r:id="rId17"/>
+    <p:sldId id="266" r:id="rId18"/>
   </p:sldIdLst>
   <p:sldSz cy="6858000" cx="12191675"/>
   <p:notesSz cx="6858000" cy="9144000"/>
@@ -11080,6 +11084,308 @@
               <a:t>Comparison focus: real-data performance + synthetic coverage diagnostics.</a:t>
             </a:r>
             <a:endParaRPr/>
+          </a:p>
+        </p:txBody>
+      </p:sp>
+    </p:spTree>
+  </p:cSld>
+  <p:clrMapOvr>
+    <a:masterClrMapping/>
+  </p:clrMapOvr>
+</p:sld>
+</file>
+
+<file path=ppt/slides/slide10.xml><?xml version="1.0" encoding="utf-8"?>
+<p:sld xmlns:a="http://schemas.openxmlformats.org/drawingml/2006/main" xmlns:p="http://schemas.openxmlformats.org/presentationml/2006/main" xmlns:r="http://schemas.openxmlformats.org/officeDocument/2006/relationships">
+  <p:cSld>
+    <p:spTree>
+      <p:nvGrpSpPr>
+        <p:cNvPr id="1" name=""/>
+        <p:cNvGrpSpPr/>
+        <p:nvPr/>
+      </p:nvGrpSpPr>
+      <p:grpSpPr/>
+      <p:sp>
+        <p:nvSpPr>
+          <p:cNvPr id="2" name="TextBox 1"/>
+          <p:cNvSpPr txBox="1"/>
+          <p:nvPr/>
+        </p:nvSpPr>
+        <p:spPr>
+          <a:xfrm>
+            <a:off x="502920" y="320040"/>
+            <a:ext cx="8046720" cy="640080"/>
+          </a:xfrm>
+          <a:prstGeom prst="rect">
+            <a:avLst/>
+          </a:prstGeom>
+          <a:noFill/>
+        </p:spPr>
+        <p:txBody>
+          <a:bodyPr wrap="none">
+            <a:spAutoFit/>
+          </a:bodyPr>
+          <a:lstStyle/>
+          <a:p>
+            <a:pPr algn="l">
+              <a:defRPr sz="2800" b="1"/>
+            </a:pPr>
+            <a:r>
+              <a:t>Final Model Selection</a:t>
+            </a:r>
+          </a:p>
+        </p:txBody>
+      </p:sp>
+      <p:sp>
+        <p:nvSpPr>
+          <p:cNvPr id="3" name="TextBox 2"/>
+          <p:cNvSpPr txBox="1"/>
+          <p:nvPr/>
+        </p:nvSpPr>
+        <p:spPr>
+          <a:xfrm>
+            <a:off x="594360" y="1097280"/>
+            <a:ext cx="7680960" cy="4480560"/>
+          </a:xfrm>
+          <a:prstGeom prst="rect">
+            <a:avLst/>
+          </a:prstGeom>
+          <a:noFill/>
+        </p:spPr>
+        <p:txBody>
+          <a:bodyPr wrap="square">
+            <a:spAutoFit/>
+          </a:bodyPr>
+          <a:lstStyle/>
+          <a:p>
+            <a:pPr>
+              <a:defRPr sz="1800"/>
+            </a:pPr>
+            <a:r>
+              <a:t>Best active model: recon_full_comp_preserve_seed3407.</a:t>
+            </a:r>
+          </a:p>
+          <a:p>
+            <a:pPr>
+              <a:defRPr sz="1800"/>
+            </a:pPr>
+            <a:r>
+              <a:t>Against recon_full_comp_preserve_curr_seed3407, the non-curr version is clearly stronger on real data.</a:t>
+            </a:r>
+          </a:p>
+          <a:p>
+            <a:pPr>
+              <a:defRPr sz="1800"/>
+            </a:pPr>
+            <a:r>
+              <a:t>test_real micro-F1: 0.811 vs 0.710; exact: 0.923 vs 0.908.</a:t>
+            </a:r>
+          </a:p>
+          <a:p>
+            <a:pPr>
+              <a:defRPr sz="1800"/>
+            </a:pPr>
+            <a:r>
+              <a:t>The curr variant is worse in both precision and recall and increases false positives on clean utterances (4 vs 13).</a:t>
+            </a:r>
+          </a:p>
+          <a:p>
+            <a:pPr>
+              <a:defRPr sz="1800"/>
+            </a:pPr>
+            <a:r>
+              <a:t>Paper scope is now the annotation tool itself: this model is the final system to evaluate thoroughly on real TalkBank data.</a:t>
+            </a:r>
+          </a:p>
+          <a:p>
+            <a:pPr>
+              <a:defRPr sz="1800"/>
+            </a:pPr>
+            <a:r>
+              <a:t>Holdout generalization remains a secondary diagnostic, not the main reporting focus for the paper.</a:t>
+            </a:r>
+          </a:p>
+        </p:txBody>
+      </p:sp>
+      <p:sp>
+        <p:nvSpPr>
+          <p:cNvPr id="4" name="TextBox 3"/>
+          <p:cNvSpPr txBox="1"/>
+          <p:nvPr/>
+        </p:nvSpPr>
+        <p:spPr>
+          <a:xfrm>
+            <a:off x="594360" y="5715000"/>
+            <a:ext cx="7589520" cy="457200"/>
+          </a:xfrm>
+          <a:prstGeom prst="rect">
+            <a:avLst/>
+          </a:prstGeom>
+          <a:noFill/>
+        </p:spPr>
+        <p:txBody>
+          <a:bodyPr wrap="none">
+            <a:spAutoFit/>
+          </a:bodyPr>
+          <a:lstStyle/>
+          <a:p>
+            <a:pPr>
+              <a:defRPr sz="1500"/>
+            </a:pPr>
+            <a:r>
+              <a:t>Next step: blinded review + external real-corpus evaluation of the final model.</a:t>
+            </a:r>
+          </a:p>
+        </p:txBody>
+      </p:sp>
+    </p:spTree>
+  </p:cSld>
+  <p:clrMapOvr>
+    <a:masterClrMapping/>
+  </p:clrMapOvr>
+</p:sld>
+</file>
+
+<file path=ppt/slides/slide11.xml><?xml version="1.0" encoding="utf-8"?>
+<p:sld xmlns:a="http://schemas.openxmlformats.org/drawingml/2006/main" xmlns:p="http://schemas.openxmlformats.org/presentationml/2006/main" xmlns:r="http://schemas.openxmlformats.org/officeDocument/2006/relationships">
+  <p:cSld>
+    <p:spTree>
+      <p:nvGrpSpPr>
+        <p:cNvPr id="1" name=""/>
+        <p:cNvGrpSpPr/>
+        <p:nvPr/>
+      </p:nvGrpSpPr>
+      <p:grpSpPr/>
+      <p:sp>
+        <p:nvSpPr>
+          <p:cNvPr id="2" name="TextBox 1"/>
+          <p:cNvSpPr txBox="1"/>
+          <p:nvPr/>
+        </p:nvSpPr>
+        <p:spPr>
+          <a:xfrm>
+            <a:off x="502920" y="320040"/>
+            <a:ext cx="8046720" cy="640080"/>
+          </a:xfrm>
+          <a:prstGeom prst="rect">
+            <a:avLst/>
+          </a:prstGeom>
+          <a:noFill/>
+        </p:spPr>
+        <p:txBody>
+          <a:bodyPr wrap="none">
+            <a:spAutoFit/>
+          </a:bodyPr>
+          <a:lstStyle/>
+          <a:p>
+            <a:pPr algn="l">
+              <a:defRPr sz="2800" b="1"/>
+            </a:pPr>
+            <a:r>
+              <a:t>Final Model: Adjudicated Evaluation</a:t>
+            </a:r>
+          </a:p>
+        </p:txBody>
+      </p:sp>
+      <p:sp>
+        <p:nvSpPr>
+          <p:cNvPr id="3" name="TextBox 2"/>
+          <p:cNvSpPr txBox="1"/>
+          <p:nvPr/>
+        </p:nvSpPr>
+        <p:spPr>
+          <a:xfrm>
+            <a:off x="594360" y="1097280"/>
+            <a:ext cx="7680960" cy="4480560"/>
+          </a:xfrm>
+          <a:prstGeom prst="rect">
+            <a:avLst/>
+          </a:prstGeom>
+          <a:noFill/>
+        </p:spPr>
+        <p:txBody>
+          <a:bodyPr wrap="square">
+            <a:spAutoFit/>
+          </a:bodyPr>
+          <a:lstStyle/>
+          <a:p>
+            <a:pPr>
+              <a:defRPr sz="1800"/>
+            </a:pPr>
+            <a:r>
+              <a:t>Final model: recon_full_comp_preserve_seed3407.</a:t>
+            </a:r>
+          </a:p>
+          <a:p>
+            <a:pPr>
+              <a:defRPr sz="1800"/>
+            </a:pPr>
+            <a:r>
+              <a:t>Automatic real-test result: 92.3% exact-match, 0.811 micro-F1.</a:t>
+            </a:r>
+          </a:p>
+          <a:p>
+            <a:pPr>
+              <a:defRPr sz="1800"/>
+            </a:pPr>
+            <a:r>
+              <a:t>Blinded post-hoc review covered all 53 disagreement utterances (106 candidate rows).</a:t>
+            </a:r>
+          </a:p>
+          <a:p>
+            <a:pPr>
+              <a:defRPr sz="1800"/>
+            </a:pPr>
+            <a:r>
+              <a:t>Strict reading: 36 acceptable disagreements, 11 clearly incorrect -&gt; 97.5% adjudicated acceptable-output rate.</a:t>
+            </a:r>
+          </a:p>
+          <a:p>
+            <a:pPr>
+              <a:defRPr sz="1800"/>
+            </a:pPr>
+            <a:r>
+              <a:t>Label-first reading: 42 acceptable disagreements -&gt; 98.4% adjudicated acceptable-output rate.</a:t>
+            </a:r>
+          </a:p>
+          <a:p>
+            <a:pPr>
+              <a:defRPr sz="1800"/>
+            </a:pPr>
+            <a:r>
+              <a:t>Interpretation: exact-match is conservative for the final model; most mismatches are acceptable labelings or partial secondary-label differences.</a:t>
+            </a:r>
+          </a:p>
+        </p:txBody>
+      </p:sp>
+      <p:sp>
+        <p:nvSpPr>
+          <p:cNvPr id="4" name="TextBox 3"/>
+          <p:cNvSpPr txBox="1"/>
+          <p:nvPr/>
+        </p:nvSpPr>
+        <p:spPr>
+          <a:xfrm>
+            <a:off x="594360" y="5715000"/>
+            <a:ext cx="7589520" cy="457200"/>
+          </a:xfrm>
+          <a:prstGeom prst="rect">
+            <a:avLst/>
+          </a:prstGeom>
+          <a:noFill/>
+        </p:spPr>
+        <p:txBody>
+          <a:bodyPr wrap="none">
+            <a:spAutoFit/>
+          </a:bodyPr>
+          <a:lstStyle/>
+          <a:p>
+            <a:pPr>
+              <a:defRPr sz="1500"/>
+            </a:pPr>
+            <a:r>
+              <a:t>Paper focus: present the annotation tool and evaluate the final model thoroughly on real TalkBank data.</a:t>
+            </a:r>
           </a:p>
         </p:txBody>
       </p:sp>
@@ -13490,6 +13796,279 @@
 </p:sld>
 </file>
 
+<file path=ppt/slides/slide8.xml><?xml version="1.0" encoding="utf-8"?>
+<p:sld xmlns:a="http://schemas.openxmlformats.org/drawingml/2006/main" xmlns:p="http://schemas.openxmlformats.org/presentationml/2006/main" xmlns:r="http://schemas.openxmlformats.org/officeDocument/2006/relationships">
+  <p:cSld>
+    <p:spTree>
+      <p:nvGrpSpPr>
+        <p:cNvPr id="1" name=""/>
+        <p:cNvGrpSpPr/>
+        <p:nvPr/>
+      </p:nvGrpSpPr>
+      <p:grpSpPr/>
+      <p:sp>
+        <p:nvSpPr>
+          <p:cNvPr id="2" name="Title 1"/>
+          <p:cNvSpPr>
+            <a:spLocks noGrp="1"/>
+          </p:cNvSpPr>
+          <p:nvPr>
+            <p:ph type="ctrTitle"/>
+          </p:nvPr>
+        </p:nvSpPr>
+        <p:spPr/>
+        <p:txBody>
+          <a:bodyPr/>
+          <a:lstStyle/>
+          <a:p>
+            <a:pPr>
+              <a:defRPr sz="3400"/>
+            </a:pPr>
+            <a:r>
+              <a:t>Update: Curriculum vs No-Curr (Adjudicated)</a:t>
+            </a:r>
+          </a:p>
+        </p:txBody>
+      </p:sp>
+      <p:sp>
+        <p:nvSpPr>
+          <p:cNvPr id="3" name="Subtitle 2"/>
+          <p:cNvSpPr>
+            <a:spLocks noGrp="1"/>
+          </p:cNvSpPr>
+          <p:nvPr>
+            <p:ph type="subTitle" idx="1"/>
+          </p:nvPr>
+        </p:nvSpPr>
+        <p:spPr/>
+        <p:txBody>
+          <a:bodyPr/>
+          <a:lstStyle/>
+          <a:p>
+            <a:pPr>
+              <a:defRPr sz="1800"/>
+            </a:pPr>
+            <a:r>
+              <a:t>Comparable setup: same nonword-only prompt/package and seed (3407); only curriculum toggle differs.</a:t>
+            </a:r>
+          </a:p>
+          <a:p>
+            <a:pPr>
+              <a:defRPr sz="1800"/>
+            </a:pPr>
+            <a:r>
+              <a:t>Automatic test_real: direct micro-F1 0.765 vs curriculum 0.747; exact 0.934 vs 0.914.</a:t>
+            </a:r>
+          </a:p>
+          <a:p>
+            <a:pPr>
+              <a:defRPr sz="1800"/>
+            </a:pPr>
+            <a:r>
+              <a:t>Blinded adjudication set: 43 disagreement utterances, 99 candidate annotations.</a:t>
+            </a:r>
+          </a:p>
+          <a:p>
+            <a:pPr>
+              <a:defRPr sz="1800"/>
+            </a:pPr>
+            <a:r>
+              <a:t>Direct clear accuracy: 31/38 = 81.6%.</a:t>
+            </a:r>
+          </a:p>
+          <a:p>
+            <a:pPr>
+              <a:defRPr sz="1800"/>
+            </a:pPr>
+            <a:r>
+              <a:t>Curriculum clear accuracy: 21/36 = 58.3%.</a:t>
+            </a:r>
+          </a:p>
+          <a:p>
+            <a:pPr>
+              <a:defRPr sz="1800"/>
+            </a:pPr>
+            <a:r>
+              <a:t>Paired outcomes: direct wins 14, curriculum wins 4, both correct 16.</a:t>
+            </a:r>
+          </a:p>
+          <a:p>
+            <a:pPr>
+              <a:defRPr sz="1800"/>
+            </a:pPr>
+            <a:r>
+              <a:t>Conclusion: after adjudication, no evidence that curriculum improves overall annotation for this seed.</a:t>
+            </a:r>
+          </a:p>
+        </p:txBody>
+      </p:sp>
+    </p:spTree>
+  </p:cSld>
+  <p:clrMapOvr>
+    <a:masterClrMapping/>
+  </p:clrMapOvr>
+</p:sld>
+</file>
+
+<file path=ppt/slides/slide9.xml><?xml version="1.0" encoding="utf-8"?>
+<p:sld xmlns:a="http://schemas.openxmlformats.org/drawingml/2006/main" xmlns:p="http://schemas.openxmlformats.org/presentationml/2006/main" xmlns:r="http://schemas.openxmlformats.org/officeDocument/2006/relationships">
+  <p:cSld>
+    <p:spTree>
+      <p:nvGrpSpPr>
+        <p:cNvPr id="1" name=""/>
+        <p:cNvGrpSpPr/>
+        <p:nvPr/>
+      </p:nvGrpSpPr>
+      <p:grpSpPr/>
+      <p:sp>
+        <p:nvSpPr>
+          <p:cNvPr id="2" name="TextBox 1"/>
+          <p:cNvSpPr txBox="1"/>
+          <p:nvPr/>
+        </p:nvSpPr>
+        <p:spPr>
+          <a:xfrm>
+            <a:off x="502920" y="320040"/>
+            <a:ext cx="8046720" cy="640080"/>
+          </a:xfrm>
+          <a:prstGeom prst="rect">
+            <a:avLst/>
+          </a:prstGeom>
+          <a:noFill/>
+        </p:spPr>
+        <p:txBody>
+          <a:bodyPr wrap="none">
+            <a:spAutoFit/>
+          </a:bodyPr>
+          <a:lstStyle/>
+          <a:p>
+            <a:pPr algn="l">
+              <a:defRPr sz="2800" b="1"/>
+            </a:pPr>
+            <a:r>
+              <a:t>Exploratory Update: Compositional Prompt + Tokens</a:t>
+            </a:r>
+          </a:p>
+        </p:txBody>
+      </p:sp>
+      <p:sp>
+        <p:nvSpPr>
+          <p:cNvPr id="3" name="TextBox 2"/>
+          <p:cNvSpPr txBox="1"/>
+          <p:nvPr/>
+        </p:nvSpPr>
+        <p:spPr>
+          <a:xfrm>
+            <a:off x="594360" y="1097280"/>
+            <a:ext cx="7589520" cy="4389120"/>
+          </a:xfrm>
+          <a:prstGeom prst="rect">
+            <a:avLst/>
+          </a:prstGeom>
+          <a:noFill/>
+        </p:spPr>
+        <p:txBody>
+          <a:bodyPr wrap="square">
+            <a:spAutoFit/>
+          </a:bodyPr>
+          <a:lstStyle/>
+          <a:p>
+            <a:pPr>
+              <a:defRPr sz="1800"/>
+            </a:pPr>
+            <a:r>
+              <a:t>Matched comparison: recon_full_comp_preserve_seed3407 vs recon_full_curr_preserve_seed3407.</a:t>
+            </a:r>
+          </a:p>
+          <a:p>
+            <a:pPr>
+              <a:defRPr sz="1800"/>
+            </a:pPr>
+            <a:r>
+              <a:t>Real test improves substantially: micro-F1 0.722 -&gt; 0.811; exact 0.898 -&gt; 0.923.</a:t>
+            </a:r>
+          </a:p>
+          <a:p>
+            <a:pPr>
+              <a:defRPr sz="1800"/>
+            </a:pPr>
+            <a:r>
+              <a:t>Main reason: much higher precision on test_real (0.729 -&gt; 0.890) with similar recall (0.714 -&gt; 0.745).</a:t>
+            </a:r>
+          </a:p>
+          <a:p>
+            <a:pPr>
+              <a:defRPr sz="1800"/>
+            </a:pPr>
+            <a:r>
+              <a:t>False positives drop sharply on clean test utterances: 17 -&gt; 4; false negatives stay at 14.</a:t>
+            </a:r>
+          </a:p>
+          <a:p>
+            <a:pPr>
+              <a:defRPr sz="1800"/>
+            </a:pPr>
+            <a:r>
+              <a:t>Coverage also improves: test_coverage micro-F1 0.907 -&gt; 0.928.</a:t>
+            </a:r>
+          </a:p>
+          <a:p>
+            <a:pPr>
+              <a:defRPr sz="1800"/>
+            </a:pPr>
+            <a:r>
+              <a:t>Implication: making the tag structure explicit helps the model apply the seen CHAT inventory more reliably on real data.</a:t>
+            </a:r>
+          </a:p>
+          <a:p>
+            <a:pPr>
+              <a:defRPr sz="1800"/>
+            </a:pPr>
+            <a:r>
+              <a:t>Caveat: holdout remains effectively unsolved and the compositional run sometimes invents unlicensed tags (e.g. [* m:++:est]).</a:t>
+            </a:r>
+          </a:p>
+        </p:txBody>
+      </p:sp>
+      <p:sp>
+        <p:nvSpPr>
+          <p:cNvPr id="4" name="TextBox 3"/>
+          <p:cNvSpPr txBox="1"/>
+          <p:nvPr/>
+        </p:nvSpPr>
+        <p:spPr>
+          <a:xfrm>
+            <a:off x="594360" y="5760720"/>
+            <a:ext cx="7498079" cy="457200"/>
+          </a:xfrm>
+          <a:prstGeom prst="rect">
+            <a:avLst/>
+          </a:prstGeom>
+          <a:noFill/>
+        </p:spPr>
+        <p:txBody>
+          <a:bodyPr wrap="none">
+            <a:spAutoFit/>
+          </a:bodyPr>
+          <a:lstStyle/>
+          <a:p>
+            <a:pPr>
+              <a:defRPr sz="1500"/>
+            </a:pPr>
+            <a:r>
+              <a:t>Current strongest real-data result in the active runs, pending blinded adjudication.</a:t>
+            </a:r>
+          </a:p>
+        </p:txBody>
+      </p:sp>
+    </p:spTree>
+  </p:cSld>
+  <p:clrMapOvr>
+    <a:masterClrMapping/>
+  </p:clrMapOvr>
+</p:sld>
+</file>
+
 <file path=ppt/theme/theme1.xml><?xml version="1.0" encoding="utf-8"?>
 <a:theme xmlns:a="http://schemas.openxmlformats.org/drawingml/2006/main" xmlns:r="http://schemas.openxmlformats.org/officeDocument/2006/relationships" name="Office Theme">
   <a:themeElements>

</xml_diff>